<commit_message>
docs: update MOTOFIX presentation deck
</commit_message>
<xml_diff>
--- a/docs/MOTOFIX_Presentation.pptx
+++ b/docs/MOTOFIX_Presentation.pptx
@@ -8028,15 +8028,7 @@
                   <a:srgbClr val="12163D"/>
                 </a:solidFill>
               </a:rPr>
-              <a:t>also determines a </a:t>
-            </a:r>
-            <a:r>
-              <a:rPr lang="en-US" sz="1000" dirty="0" smtClean="0">
-                <a:solidFill>
-                  <a:srgbClr val="12163D"/>
-                </a:solidFill>
-              </a:rPr>
-              <a:t>fair </a:t>
+              <a:t>also determines a fair </a:t>
             </a:r>
             <a:r>
               <a:rPr lang="en-US" sz="1000" dirty="0">
@@ -9122,7 +9114,23 @@
                   <a:srgbClr val="FFB930"/>
                 </a:solidFill>
               </a:rPr>
-              <a:t>9 Microservices + PostgreSQL</a:t>
+              <a:t>8</a:t>
+            </a:r>
+            <a:r>
+              <a:rPr lang="en-US" sz="1400" b="1" smtClean="0">
+                <a:solidFill>
+                  <a:srgbClr val="FFB930"/>
+                </a:solidFill>
+              </a:rPr>
+              <a:t> </a:t>
+            </a:r>
+            <a:r>
+              <a:rPr lang="en-US" sz="1400" b="1" dirty="0">
+                <a:solidFill>
+                  <a:srgbClr val="FFB930"/>
+                </a:solidFill>
+              </a:rPr>
+              <a:t>Microservices + PostgreSQL</a:t>
             </a:r>
             <a:endParaRPr lang="en-US" sz="1400" dirty="0"/>
           </a:p>
@@ -9459,31 +9467,15 @@
                   <a:srgbClr val="F4F5FF"/>
                 </a:solidFill>
               </a:rPr>
-              <a:t>(Haiku LLM) </a:t>
-            </a:r>
-            <a:r>
-              <a:rPr lang="en-US" sz="1200" dirty="0" smtClean="0">
+              <a:t>(Haiku LLM) for </a:t>
+            </a:r>
+            <a:r>
+              <a:rPr lang="en-US" sz="1200" dirty="0">
                 <a:solidFill>
                   <a:srgbClr val="F4F5FF"/>
                 </a:solidFill>
               </a:rPr>
-              <a:t>for </a:t>
-            </a:r>
-            <a:r>
-              <a:rPr lang="en-US" sz="1200" dirty="0">
-                <a:solidFill>
-                  <a:srgbClr val="F4F5FF"/>
-                </a:solidFill>
-              </a:rPr>
-              <a:t>AI  ·  Google Maps for location  ·  MTN/Airtel for Mobile </a:t>
-            </a:r>
-            <a:r>
-              <a:rPr lang="en-US" sz="1200" dirty="0">
-                <a:solidFill>
-                  <a:srgbClr val="F4F5FF"/>
-                </a:solidFill>
-              </a:rPr>
-              <a:t>Money </a:t>
+              <a:t>AI  ·  Google Maps for location  ·  MTN/Airtel for Mobile Money </a:t>
             </a:r>
             <a:r>
               <a:rPr lang="en-US" sz="1200" dirty="0" smtClean="0">

</xml_diff>